<commit_message>
Small updates and corrections to slides
</commit_message>
<xml_diff>
--- a/LectureSlides/10a_ModelsInHighDimensions.pptx
+++ b/LectureSlides/10a_ModelsInHighDimensions.pptx
@@ -263,7 +263,7 @@
           <a:p>
             <a:fld id="{BE0C07B0-B271-4EE5-BA4D-B7A9BA86B818}" type="datetimeFigureOut">
               <a:rPr lang="en-US" smtClean="0"/>
-              <a:t>10/9/2025</a:t>
+              <a:t>2/17/2026</a:t>
             </a:fld>
             <a:endParaRPr lang="en-US"/>
           </a:p>
@@ -709,7 +709,7 @@
           <a:p>
             <a:fld id="{241EB5C9-1307-BA42-ABA2-0BC069CD8E7F}" type="datetimeFigureOut">
               <a:rPr lang="en-US" smtClean="0"/>
-              <a:t>10/9/2025</a:t>
+              <a:t>2/17/2026</a:t>
             </a:fld>
             <a:endParaRPr lang="en-US"/>
           </a:p>
@@ -877,7 +877,7 @@
           <a:p>
             <a:fld id="{241EB5C9-1307-BA42-ABA2-0BC069CD8E7F}" type="datetimeFigureOut">
               <a:rPr lang="en-US" smtClean="0"/>
-              <a:t>10/9/2025</a:t>
+              <a:t>2/17/2026</a:t>
             </a:fld>
             <a:endParaRPr lang="en-US"/>
           </a:p>
@@ -1055,7 +1055,7 @@
           <a:p>
             <a:fld id="{241EB5C9-1307-BA42-ABA2-0BC069CD8E7F}" type="datetimeFigureOut">
               <a:rPr lang="en-US" smtClean="0"/>
-              <a:t>10/9/2025</a:t>
+              <a:t>2/17/2026</a:t>
             </a:fld>
             <a:endParaRPr lang="en-US"/>
           </a:p>
@@ -1373,7 +1373,7 @@
           <a:p>
             <a:fld id="{241EB5C9-1307-BA42-ABA2-0BC069CD8E7F}" type="datetimeFigureOut">
               <a:rPr lang="en-US" smtClean="0"/>
-              <a:t>10/9/2025</a:t>
+              <a:t>2/17/2026</a:t>
             </a:fld>
             <a:endParaRPr lang="en-US"/>
           </a:p>
@@ -1618,7 +1618,7 @@
           <a:p>
             <a:fld id="{241EB5C9-1307-BA42-ABA2-0BC069CD8E7F}" type="datetimeFigureOut">
               <a:rPr lang="en-US" smtClean="0"/>
-              <a:t>10/9/2025</a:t>
+              <a:t>2/17/2026</a:t>
             </a:fld>
             <a:endParaRPr lang="en-US"/>
           </a:p>
@@ -1903,7 +1903,7 @@
           <a:p>
             <a:fld id="{241EB5C9-1307-BA42-ABA2-0BC069CD8E7F}" type="datetimeFigureOut">
               <a:rPr lang="en-US" smtClean="0"/>
-              <a:t>10/9/2025</a:t>
+              <a:t>2/17/2026</a:t>
             </a:fld>
             <a:endParaRPr lang="en-US"/>
           </a:p>
@@ -2322,7 +2322,7 @@
           <a:p>
             <a:fld id="{241EB5C9-1307-BA42-ABA2-0BC069CD8E7F}" type="datetimeFigureOut">
               <a:rPr lang="en-US" smtClean="0"/>
-              <a:t>10/9/2025</a:t>
+              <a:t>2/17/2026</a:t>
             </a:fld>
             <a:endParaRPr lang="en-US"/>
           </a:p>
@@ -2439,7 +2439,7 @@
           <a:p>
             <a:fld id="{241EB5C9-1307-BA42-ABA2-0BC069CD8E7F}" type="datetimeFigureOut">
               <a:rPr lang="en-US" smtClean="0"/>
-              <a:t>10/9/2025</a:t>
+              <a:t>2/17/2026</a:t>
             </a:fld>
             <a:endParaRPr lang="en-US"/>
           </a:p>
@@ -2534,7 +2534,7 @@
           <a:p>
             <a:fld id="{241EB5C9-1307-BA42-ABA2-0BC069CD8E7F}" type="datetimeFigureOut">
               <a:rPr lang="en-US" smtClean="0"/>
-              <a:t>10/9/2025</a:t>
+              <a:t>2/17/2026</a:t>
             </a:fld>
             <a:endParaRPr lang="en-US"/>
           </a:p>
@@ -2809,7 +2809,7 @@
           <a:p>
             <a:fld id="{241EB5C9-1307-BA42-ABA2-0BC069CD8E7F}" type="datetimeFigureOut">
               <a:rPr lang="en-US" smtClean="0"/>
-              <a:t>10/9/2025</a:t>
+              <a:t>2/17/2026</a:t>
             </a:fld>
             <a:endParaRPr lang="en-US"/>
           </a:p>
@@ -3061,7 +3061,7 @@
           <a:p>
             <a:fld id="{241EB5C9-1307-BA42-ABA2-0BC069CD8E7F}" type="datetimeFigureOut">
               <a:rPr lang="en-US" smtClean="0"/>
-              <a:t>10/9/2025</a:t>
+              <a:t>2/17/2026</a:t>
             </a:fld>
             <a:endParaRPr lang="en-US"/>
           </a:p>
@@ -3272,7 +3272,7 @@
           <a:p>
             <a:fld id="{241EB5C9-1307-BA42-ABA2-0BC069CD8E7F}" type="datetimeFigureOut">
               <a:rPr lang="en-US" smtClean="0"/>
-              <a:t>10/9/2025</a:t>
+              <a:t>2/17/2026</a:t>
             </a:fld>
             <a:endParaRPr lang="en-US"/>
           </a:p>
@@ -15212,8 +15212,8 @@
           </a:p>
         </p:txBody>
       </p:sp>
-      <mc:AlternateContent xmlns:mc="http://schemas.openxmlformats.org/markup-compatibility/2006">
-        <mc:Choice xmlns:a14="http://schemas.microsoft.com/office/drawing/2010/main" Requires="a14">
+      <mc:AlternateContent xmlns:mc="http://schemas.openxmlformats.org/markup-compatibility/2006" xmlns:a14="http://schemas.microsoft.com/office/drawing/2010/main">
+        <mc:Choice Requires="a14">
           <p:sp>
             <p:nvSpPr>
               <p:cNvPr id="3" name="Content Placeholder 2"/>
@@ -15286,13 +15286,7 @@
                                 <a:rPr lang="en-US" b="0" i="1" smtClean="0">
                                   <a:latin typeface="Cambria Math" panose="02040503050406030204" pitchFamily="18" charset="0"/>
                                 </a:rPr>
-                                <m:t>𝐴</m:t>
-                              </m:r>
-                              <m:r>
-                                <a:rPr lang="en-US" b="0" i="1" smtClean="0">
-                                  <a:latin typeface="Cambria Math" panose="02040503050406030204" pitchFamily="18" charset="0"/>
-                                </a:rPr>
-                                <m:t>𝑏</m:t>
+                                <m:t>𝐴𝑏</m:t>
                               </m:r>
                               <m:r>
                                 <a:rPr lang="en-US" b="0" i="1" smtClean="0">
@@ -15953,7 +15947,7 @@
             </p:txBody>
           </p:sp>
         </mc:Choice>
-        <mc:Fallback>
+        <mc:Fallback xmlns="">
           <p:sp>
             <p:nvSpPr>
               <p:cNvPr id="3" name="Content Placeholder 2"/>
@@ -21341,8 +21335,8 @@
           </a:p>
         </p:txBody>
       </p:sp>
-      <mc:AlternateContent xmlns:mc="http://schemas.openxmlformats.org/markup-compatibility/2006">
-        <mc:Choice xmlns:a14="http://schemas.microsoft.com/office/drawing/2010/main" Requires="a14">
+      <mc:AlternateContent xmlns:mc="http://schemas.openxmlformats.org/markup-compatibility/2006" xmlns:a14="http://schemas.microsoft.com/office/drawing/2010/main">
+        <mc:Choice Requires="a14">
           <p:sp>
             <p:nvSpPr>
               <p:cNvPr id="3" name="Content Placeholder 2"/>
@@ -21738,7 +21732,7 @@
             </p:txBody>
           </p:sp>
         </mc:Choice>
-        <mc:Fallback>
+        <mc:Fallback xmlns="">
           <p:sp>
             <p:nvSpPr>
               <p:cNvPr id="3" name="Content Placeholder 2"/>
@@ -21826,8 +21820,8 @@
           </a:p>
         </p:txBody>
       </p:sp>
-      <mc:AlternateContent xmlns:mc="http://schemas.openxmlformats.org/markup-compatibility/2006">
-        <mc:Choice xmlns:a14="http://schemas.microsoft.com/office/drawing/2010/main" Requires="a14">
+      <mc:AlternateContent xmlns:mc="http://schemas.openxmlformats.org/markup-compatibility/2006" xmlns:a14="http://schemas.microsoft.com/office/drawing/2010/main">
+        <mc:Choice Requires="a14">
           <p:sp>
             <p:nvSpPr>
               <p:cNvPr id="3" name="Content Placeholder 2"/>
@@ -22714,7 +22708,7 @@
             </p:txBody>
           </p:sp>
         </mc:Choice>
-        <mc:Fallback>
+        <mc:Fallback xmlns="">
           <p:sp>
             <p:nvSpPr>
               <p:cNvPr id="3" name="Content Placeholder 2"/>
@@ -22801,8 +22795,8 @@
           </a:p>
         </p:txBody>
       </p:sp>
-      <mc:AlternateContent xmlns:mc="http://schemas.openxmlformats.org/markup-compatibility/2006" xmlns:a14="http://schemas.microsoft.com/office/drawing/2010/main">
-        <mc:Choice Requires="a14">
+      <mc:AlternateContent xmlns:mc="http://schemas.openxmlformats.org/markup-compatibility/2006">
+        <mc:Choice xmlns:a14="http://schemas.microsoft.com/office/drawing/2010/main" Requires="a14">
           <p:sp>
             <p:nvSpPr>
               <p:cNvPr id="3" name="Content Placeholder 2"/>
@@ -23006,7 +23000,7 @@
                 <a:pPr lvl="1"/>
                 <a:r>
                   <a:rPr lang="en-US" dirty="0"/>
-                  <a:t>This creates a so called </a:t>
+                  <a:t>This creates a so-called </a:t>
                 </a:r>
                 <a:r>
                   <a:rPr lang="en-US" b="1" dirty="0"/>
@@ -23239,7 +23233,7 @@
             </p:txBody>
           </p:sp>
         </mc:Choice>
-        <mc:Fallback xmlns="">
+        <mc:Fallback>
           <p:sp>
             <p:nvSpPr>
               <p:cNvPr id="3" name="Content Placeholder 2"/>
@@ -28588,8 +28582,8 @@
           </a:p>
         </p:txBody>
       </p:sp>
-      <mc:AlternateContent xmlns:mc="http://schemas.openxmlformats.org/markup-compatibility/2006">
-        <mc:Choice xmlns:a14="http://schemas.microsoft.com/office/drawing/2010/main" Requires="a14">
+      <mc:AlternateContent xmlns:mc="http://schemas.openxmlformats.org/markup-compatibility/2006" xmlns:a14="http://schemas.microsoft.com/office/drawing/2010/main">
+        <mc:Choice Requires="a14">
           <p:sp>
             <p:nvSpPr>
               <p:cNvPr id="3" name="Content Placeholder 2"/>
@@ -29250,7 +29244,7 @@
             </p:txBody>
           </p:sp>
         </mc:Choice>
-        <mc:Fallback>
+        <mc:Fallback xmlns="">
           <p:sp>
             <p:nvSpPr>
               <p:cNvPr id="3" name="Content Placeholder 2"/>
@@ -31231,8 +31225,8 @@
           </a:p>
         </p:txBody>
       </p:sp>
-      <mc:AlternateContent xmlns:mc="http://schemas.openxmlformats.org/markup-compatibility/2006">
-        <mc:Choice xmlns:a14="http://schemas.microsoft.com/office/drawing/2010/main" Requires="a14">
+      <mc:AlternateContent xmlns:mc="http://schemas.openxmlformats.org/markup-compatibility/2006" xmlns:a14="http://schemas.microsoft.com/office/drawing/2010/main">
+        <mc:Choice Requires="a14">
           <p:sp>
             <p:nvSpPr>
               <p:cNvPr id="3" name="Content Placeholder 2"/>
@@ -31466,13 +31460,7 @@
                                     <a:rPr lang="en-US" b="0" i="1" smtClean="0">
                                       <a:latin typeface="Cambria Math" panose="02040503050406030204" pitchFamily="18" charset="0"/>
                                     </a:rPr>
-                                    <m:t>𝐴</m:t>
-                                  </m:r>
-                                  <m:r>
-                                    <a:rPr lang="en-US" b="0" i="1" smtClean="0">
-                                      <a:latin typeface="Cambria Math" panose="02040503050406030204" pitchFamily="18" charset="0"/>
-                                    </a:rPr>
-                                    <m:t>𝑏</m:t>
+                                    <m:t>𝐴𝑏</m:t>
                                   </m:r>
                                   <m:r>
                                     <a:rPr lang="en-US" b="0" i="1" smtClean="0">
@@ -31697,7 +31685,7 @@
             </p:txBody>
           </p:sp>
         </mc:Choice>
-        <mc:Fallback>
+        <mc:Fallback xmlns="">
           <p:sp>
             <p:nvSpPr>
               <p:cNvPr id="3" name="Content Placeholder 2"/>

</xml_diff>